<commit_message>
Implemented Bryce's presentation advice
</commit_message>
<xml_diff>
--- a/Mid project Update.pptx
+++ b/Mid project Update.pptx
@@ -310,7 +310,7 @@
           <a:p>
             <a:fld id="{82AFC869-5EEF-42A8-8244-0DD91ADCD842}" type="datetimeFigureOut">
               <a:rPr lang="en-NZ" smtClean="0"/>
-              <a:t>12/09/2026</a:t>
+              <a:t>14/09/2026</a:t>
             </a:fld>
             <a:endParaRPr lang="en-NZ"/>
           </a:p>
@@ -585,7 +585,7 @@
           <a:p>
             <a:fld id="{82AFC869-5EEF-42A8-8244-0DD91ADCD842}" type="datetimeFigureOut">
               <a:rPr lang="en-NZ" smtClean="0"/>
-              <a:t>12/09/2026</a:t>
+              <a:t>14/09/2026</a:t>
             </a:fld>
             <a:endParaRPr lang="en-NZ"/>
           </a:p>
@@ -779,7 +779,7 @@
           <a:p>
             <a:fld id="{82AFC869-5EEF-42A8-8244-0DD91ADCD842}" type="datetimeFigureOut">
               <a:rPr lang="en-NZ" smtClean="0"/>
-              <a:t>12/09/2026</a:t>
+              <a:t>14/09/2026</a:t>
             </a:fld>
             <a:endParaRPr lang="en-NZ"/>
           </a:p>
@@ -1052,7 +1052,7 @@
           <a:p>
             <a:fld id="{82AFC869-5EEF-42A8-8244-0DD91ADCD842}" type="datetimeFigureOut">
               <a:rPr lang="en-NZ" smtClean="0"/>
-              <a:t>12/09/2026</a:t>
+              <a:t>14/09/2026</a:t>
             </a:fld>
             <a:endParaRPr lang="en-NZ"/>
           </a:p>
@@ -1393,7 +1393,7 @@
           <a:p>
             <a:fld id="{82AFC869-5EEF-42A8-8244-0DD91ADCD842}" type="datetimeFigureOut">
               <a:rPr lang="en-NZ" smtClean="0"/>
-              <a:t>12/09/2026</a:t>
+              <a:t>14/09/2026</a:t>
             </a:fld>
             <a:endParaRPr lang="en-NZ"/>
           </a:p>
@@ -2016,7 +2016,7 @@
           <a:p>
             <a:fld id="{82AFC869-5EEF-42A8-8244-0DD91ADCD842}" type="datetimeFigureOut">
               <a:rPr lang="en-NZ" smtClean="0"/>
-              <a:t>12/09/2026</a:t>
+              <a:t>14/09/2026</a:t>
             </a:fld>
             <a:endParaRPr lang="en-NZ"/>
           </a:p>
@@ -2876,7 +2876,7 @@
           <a:p>
             <a:fld id="{82AFC869-5EEF-42A8-8244-0DD91ADCD842}" type="datetimeFigureOut">
               <a:rPr lang="en-NZ" smtClean="0"/>
-              <a:t>12/09/2026</a:t>
+              <a:t>14/09/2026</a:t>
             </a:fld>
             <a:endParaRPr lang="en-NZ"/>
           </a:p>
@@ -3046,7 +3046,7 @@
           <a:p>
             <a:fld id="{82AFC869-5EEF-42A8-8244-0DD91ADCD842}" type="datetimeFigureOut">
               <a:rPr lang="en-NZ" smtClean="0"/>
-              <a:t>12/09/2026</a:t>
+              <a:t>14/09/2026</a:t>
             </a:fld>
             <a:endParaRPr lang="en-NZ"/>
           </a:p>
@@ -3226,7 +3226,7 @@
           <a:p>
             <a:fld id="{82AFC869-5EEF-42A8-8244-0DD91ADCD842}" type="datetimeFigureOut">
               <a:rPr lang="en-NZ" smtClean="0"/>
-              <a:t>12/09/2026</a:t>
+              <a:t>14/09/2026</a:t>
             </a:fld>
             <a:endParaRPr lang="en-NZ"/>
           </a:p>
@@ -3396,7 +3396,7 @@
           <a:p>
             <a:fld id="{82AFC869-5EEF-42A8-8244-0DD91ADCD842}" type="datetimeFigureOut">
               <a:rPr lang="en-NZ" smtClean="0"/>
-              <a:t>12/09/2026</a:t>
+              <a:t>14/09/2026</a:t>
             </a:fld>
             <a:endParaRPr lang="en-NZ"/>
           </a:p>
@@ -3643,7 +3643,7 @@
           <a:p>
             <a:fld id="{82AFC869-5EEF-42A8-8244-0DD91ADCD842}" type="datetimeFigureOut">
               <a:rPr lang="en-NZ" smtClean="0"/>
-              <a:t>12/09/2026</a:t>
+              <a:t>14/09/2026</a:t>
             </a:fld>
             <a:endParaRPr lang="en-NZ"/>
           </a:p>
@@ -3935,7 +3935,7 @@
           <a:p>
             <a:fld id="{82AFC869-5EEF-42A8-8244-0DD91ADCD842}" type="datetimeFigureOut">
               <a:rPr lang="en-NZ" smtClean="0"/>
-              <a:t>12/09/2026</a:t>
+              <a:t>14/09/2026</a:t>
             </a:fld>
             <a:endParaRPr lang="en-NZ"/>
           </a:p>
@@ -4379,7 +4379,7 @@
           <a:p>
             <a:fld id="{82AFC869-5EEF-42A8-8244-0DD91ADCD842}" type="datetimeFigureOut">
               <a:rPr lang="en-NZ" smtClean="0"/>
-              <a:t>12/09/2026</a:t>
+              <a:t>14/09/2026</a:t>
             </a:fld>
             <a:endParaRPr lang="en-NZ"/>
           </a:p>
@@ -4497,7 +4497,7 @@
           <a:p>
             <a:fld id="{82AFC869-5EEF-42A8-8244-0DD91ADCD842}" type="datetimeFigureOut">
               <a:rPr lang="en-NZ" smtClean="0"/>
-              <a:t>12/09/2026</a:t>
+              <a:t>14/09/2026</a:t>
             </a:fld>
             <a:endParaRPr lang="en-NZ"/>
           </a:p>
@@ -4592,7 +4592,7 @@
           <a:p>
             <a:fld id="{82AFC869-5EEF-42A8-8244-0DD91ADCD842}" type="datetimeFigureOut">
               <a:rPr lang="en-NZ" smtClean="0"/>
-              <a:t>12/09/2026</a:t>
+              <a:t>14/09/2026</a:t>
             </a:fld>
             <a:endParaRPr lang="en-NZ"/>
           </a:p>
@@ -4871,7 +4871,7 @@
           <a:p>
             <a:fld id="{82AFC869-5EEF-42A8-8244-0DD91ADCD842}" type="datetimeFigureOut">
               <a:rPr lang="en-NZ" smtClean="0"/>
-              <a:t>12/09/2026</a:t>
+              <a:t>14/09/2026</a:t>
             </a:fld>
             <a:endParaRPr lang="en-NZ"/>
           </a:p>
@@ -5146,7 +5146,7 @@
           <a:p>
             <a:fld id="{82AFC869-5EEF-42A8-8244-0DD91ADCD842}" type="datetimeFigureOut">
               <a:rPr lang="en-NZ" smtClean="0"/>
-              <a:t>12/09/2026</a:t>
+              <a:t>14/09/2026</a:t>
             </a:fld>
             <a:endParaRPr lang="en-NZ"/>
           </a:p>
@@ -5589,7 +5589,7 @@
           <a:p>
             <a:fld id="{82AFC869-5EEF-42A8-8244-0DD91ADCD842}" type="datetimeFigureOut">
               <a:rPr lang="en-NZ" smtClean="0"/>
-              <a:t>12/09/2026</a:t>
+              <a:t>14/09/2026</a:t>
             </a:fld>
             <a:endParaRPr lang="en-NZ"/>
           </a:p>

</xml_diff>